<commit_message>
updated lessons 1, 4, 5, 6
</commit_message>
<xml_diff>
--- a/docs/assets/slides/OutbackRobots_Lesson4_Slides_WhatIsAI.pptx
+++ b/docs/assets/slides/OutbackRobots_Lesson4_Slides_WhatIsAI.pptx
@@ -5,7 +5,7 @@
     <p:sldMasterId id="2147483648" r:id="rId1"/>
   </p:sldMasterIdLst>
   <p:notesMasterIdLst>
-    <p:notesMasterId r:id="rId20"/>
+    <p:notesMasterId r:id="rId22"/>
   </p:notesMasterIdLst>
   <p:sldIdLst>
     <p:sldId id="372" r:id="rId2"/>
@@ -24,20 +24,22 @@
     <p:sldId id="382" r:id="rId15"/>
     <p:sldId id="386" r:id="rId16"/>
     <p:sldId id="384" r:id="rId17"/>
-    <p:sldId id="371" r:id="rId18"/>
-    <p:sldId id="355" r:id="rId19"/>
+    <p:sldId id="424" r:id="rId18"/>
+    <p:sldId id="425" r:id="rId19"/>
+    <p:sldId id="371" r:id="rId20"/>
+    <p:sldId id="355" r:id="rId21"/>
   </p:sldIdLst>
   <p:sldSz cx="9906000" cy="6858000" type="A4"/>
   <p:notesSz cx="7099300" cy="10234613"/>
   <p:embeddedFontLst>
     <p:embeddedFont>
       <p:font typeface="Berlin Sans FB" panose="020E0602020502020306" pitchFamily="34" charset="0"/>
-      <p:regular r:id="rId21"/>
-      <p:bold r:id="rId22"/>
+      <p:regular r:id="rId23"/>
+      <p:bold r:id="rId24"/>
     </p:embeddedFont>
     <p:embeddedFont>
       <p:font typeface="Berlin Sans FB Demi" panose="020E0802020502020306" pitchFamily="34" charset="0"/>
-      <p:bold r:id="rId23"/>
+      <p:bold r:id="rId25"/>
     </p:embeddedFont>
   </p:embeddedFontLst>
   <p:defaultTextStyle>
@@ -160,6 +162,8 @@
             <p14:sldId id="382"/>
             <p14:sldId id="386"/>
             <p14:sldId id="384"/>
+            <p14:sldId id="424"/>
+            <p14:sldId id="425"/>
           </p14:sldIdLst>
         </p14:section>
         <p14:section name="Wrap Up" id="{85C9C7DE-C9E5-404F-B6C1-4A2C78765023}">
@@ -198,9 +202,60 @@
 <file path=ppt/revisionInfo.xml><?xml version="1.0" encoding="utf-8"?>
 <p1510:revInfo xmlns:a="http://schemas.openxmlformats.org/drawingml/2006/main" xmlns:r="http://schemas.openxmlformats.org/officeDocument/2006/relationships" xmlns:p1510="http://schemas.microsoft.com/office/powerpoint/2015/10/main">
   <p1510:revLst>
-    <p1510:client id="{FE70A998-E95C-4EA5-98B0-DE235C68AE67}" v="3" dt="2026-03-09T23:07:26.981"/>
+    <p1510:client id="{01B576E6-8302-45A8-A2BD-06E6228AAEC1}" v="2" dt="2026-05-22T02:21:37.539"/>
   </p1510:revLst>
 </p1510:revInfo>
+</file>
+
+<file path=ppt/changesInfos/changesInfo1.xml><?xml version="1.0" encoding="utf-8"?>
+<pc:chgInfo xmlns:a="http://schemas.openxmlformats.org/drawingml/2006/main" xmlns:r="http://schemas.openxmlformats.org/officeDocument/2006/relationships" xmlns:ac="http://schemas.microsoft.com/office/drawing/2013/main/command" xmlns:pc="http://schemas.microsoft.com/office/powerpoint/2013/main/command">
+  <pc:docChgLst>
+    <pc:chgData name="Ben Kelly" userId="79179b44-934c-4bdd-82f6-75b69b2eecee" providerId="ADAL" clId="{A042A029-C61D-4345-AC60-70288B726536}"/>
+    <pc:docChg chg="custSel addSld modSld">
+      <pc:chgData name="Ben Kelly" userId="79179b44-934c-4bdd-82f6-75b69b2eecee" providerId="ADAL" clId="{A042A029-C61D-4345-AC60-70288B726536}" dt="2026-05-22T02:21:37.536" v="7"/>
+      <pc:docMkLst>
+        <pc:docMk/>
+      </pc:docMkLst>
+      <pc:sldChg chg="addSp delSp mod">
+        <pc:chgData name="Ben Kelly" userId="79179b44-934c-4bdd-82f6-75b69b2eecee" providerId="ADAL" clId="{A042A029-C61D-4345-AC60-70288B726536}" dt="2026-05-22T02:20:59.077" v="1" actId="478"/>
+        <pc:sldMkLst>
+          <pc:docMk/>
+          <pc:sldMk cId="2875814511" sldId="384"/>
+        </pc:sldMkLst>
+        <pc:picChg chg="add del">
+          <ac:chgData name="Ben Kelly" userId="79179b44-934c-4bdd-82f6-75b69b2eecee" providerId="ADAL" clId="{A042A029-C61D-4345-AC60-70288B726536}" dt="2026-05-22T02:20:59.077" v="1" actId="478"/>
+          <ac:picMkLst>
+            <pc:docMk/>
+            <pc:sldMk cId="2875814511" sldId="384"/>
+            <ac:picMk id="6" creationId="{C29ECD9E-DA0C-7181-9FC5-160B39E1DCC1}"/>
+          </ac:picMkLst>
+        </pc:picChg>
+      </pc:sldChg>
+      <pc:sldChg chg="modSp add mod">
+        <pc:chgData name="Ben Kelly" userId="79179b44-934c-4bdd-82f6-75b69b2eecee" providerId="ADAL" clId="{A042A029-C61D-4345-AC60-70288B726536}" dt="2026-05-22T02:21:14.676" v="6" actId="20577"/>
+        <pc:sldMkLst>
+          <pc:docMk/>
+          <pc:sldMk cId="2124365965" sldId="424"/>
+        </pc:sldMkLst>
+        <pc:spChg chg="mod">
+          <ac:chgData name="Ben Kelly" userId="79179b44-934c-4bdd-82f6-75b69b2eecee" providerId="ADAL" clId="{A042A029-C61D-4345-AC60-70288B726536}" dt="2026-05-22T02:21:14.676" v="6" actId="20577"/>
+          <ac:spMkLst>
+            <pc:docMk/>
+            <pc:sldMk cId="2124365965" sldId="424"/>
+            <ac:spMk id="3" creationId="{6BDFB0D9-8361-CCB3-4195-D528A68F2236}"/>
+          </ac:spMkLst>
+        </pc:spChg>
+      </pc:sldChg>
+      <pc:sldChg chg="add">
+        <pc:chgData name="Ben Kelly" userId="79179b44-934c-4bdd-82f6-75b69b2eecee" providerId="ADAL" clId="{A042A029-C61D-4345-AC60-70288B726536}" dt="2026-05-22T02:21:37.536" v="7"/>
+        <pc:sldMkLst>
+          <pc:docMk/>
+          <pc:sldMk cId="494497314" sldId="425"/>
+        </pc:sldMkLst>
+      </pc:sldChg>
+    </pc:docChg>
+  </pc:docChgLst>
+</pc:chgInfo>
 </file>
 
 <file path=ppt/notesMasters/notesMaster1.xml><?xml version="1.0" encoding="utf-8"?>
@@ -285,7 +340,7 @@
           <a:p>
             <a:fld id="{4F3F5AEF-4F6C-41E2-869B-89F90C9BC9CB}" type="datetimeFigureOut">
               <a:rPr lang="en-US" smtClean="0"/>
-              <a:t>3/13/2026</a:t>
+              <a:t>5/22/2026</a:t>
             </a:fld>
             <a:endParaRPr lang="en-US"/>
           </a:p>
@@ -815,7 +870,7 @@
           <a:p>
             <a:fld id="{0C641F1D-C242-463A-9118-CEC8A32732E1}" type="datetime1">
               <a:rPr lang="en-US" smtClean="0"/>
-              <a:t>3/13/2026</a:t>
+              <a:t>5/22/2026</a:t>
             </a:fld>
             <a:endParaRPr lang="en-US"/>
           </a:p>
@@ -1938,7 +1993,7 @@
           <a:p>
             <a:fld id="{6C3E4B74-615C-44D1-8875-0F95FDB4ACF1}" type="datetime1">
               <a:rPr lang="en-US" smtClean="0"/>
-              <a:t>3/13/2026</a:t>
+              <a:t>5/22/2026</a:t>
             </a:fld>
             <a:endParaRPr lang="en-US"/>
           </a:p>
@@ -2186,7 +2241,7 @@
           <a:p>
             <a:fld id="{ED101441-3954-4234-8E77-79F8676957CB}" type="datetime1">
               <a:rPr lang="en-US" smtClean="0"/>
-              <a:t>3/13/2026</a:t>
+              <a:t>5/22/2026</a:t>
             </a:fld>
             <a:endParaRPr lang="en-US"/>
           </a:p>
@@ -2350,7 +2405,7 @@
           <a:p>
             <a:fld id="{FE5290FD-71D0-407D-83AB-396A7FD0C9D0}" type="datetime1">
               <a:rPr lang="en-US" smtClean="0"/>
-              <a:t>3/13/2026</a:t>
+              <a:t>5/22/2026</a:t>
             </a:fld>
             <a:endParaRPr lang="en-US"/>
           </a:p>
@@ -2524,7 +2579,7 @@
           <a:p>
             <a:fld id="{C1019B73-AB8A-401C-A09D-1C931BCE90B8}" type="datetime1">
               <a:rPr lang="en-US" smtClean="0"/>
-              <a:t>3/13/2026</a:t>
+              <a:t>5/22/2026</a:t>
             </a:fld>
             <a:endParaRPr lang="en-US"/>
           </a:p>
@@ -2688,7 +2743,7 @@
           <a:p>
             <a:fld id="{D1C8F71B-FE01-41BB-BA09-F81DE1617D4D}" type="datetime1">
               <a:rPr lang="en-US" smtClean="0"/>
-              <a:t>3/13/2026</a:t>
+              <a:t>5/22/2026</a:t>
             </a:fld>
             <a:endParaRPr lang="en-US"/>
           </a:p>
@@ -2929,7 +2984,7 @@
           <a:p>
             <a:fld id="{3C1A2404-A312-4657-8292-B0E4B798C0E7}" type="datetime1">
               <a:rPr lang="en-US" smtClean="0"/>
-              <a:t>3/13/2026</a:t>
+              <a:t>5/22/2026</a:t>
             </a:fld>
             <a:endParaRPr lang="en-US"/>
           </a:p>
@@ -3210,7 +3265,7 @@
           <a:p>
             <a:fld id="{A9944A73-44BC-44C3-B99F-A0232951B267}" type="datetime1">
               <a:rPr lang="en-US" smtClean="0"/>
-              <a:t>3/13/2026</a:t>
+              <a:t>5/22/2026</a:t>
             </a:fld>
             <a:endParaRPr lang="en-US"/>
           </a:p>
@@ -3625,7 +3680,7 @@
           <a:p>
             <a:fld id="{FED12FDD-77D0-4A09-A7BF-76E5C63CBF2F}" type="datetime1">
               <a:rPr lang="en-US" smtClean="0"/>
-              <a:t>3/13/2026</a:t>
+              <a:t>5/22/2026</a:t>
             </a:fld>
             <a:endParaRPr lang="en-US"/>
           </a:p>
@@ -3738,7 +3793,7 @@
           <a:p>
             <a:fld id="{1BE876FE-512A-4774-A2B9-2BDC34E4BD18}" type="datetime1">
               <a:rPr lang="en-US" smtClean="0"/>
-              <a:t>3/13/2026</a:t>
+              <a:t>5/22/2026</a:t>
             </a:fld>
             <a:endParaRPr lang="en-US"/>
           </a:p>
@@ -5048,7 +5103,7 @@
           <a:p>
             <a:fld id="{8BF02AB2-EABE-44C0-9D58-D80514717591}" type="datetime1">
               <a:rPr lang="en-US" smtClean="0"/>
-              <a:t>3/13/2026</a:t>
+              <a:t>5/22/2026</a:t>
             </a:fld>
             <a:endParaRPr lang="en-US"/>
           </a:p>
@@ -6930,7 +6985,7 @@
           <p:cNvPr id="2" name="Slide Number Placeholder 1">
             <a:extLst>
               <a:ext uri="{FF2B5EF4-FFF2-40B4-BE49-F238E27FC236}">
-                <a16:creationId xmlns:a16="http://schemas.microsoft.com/office/drawing/2014/main" id="{FF3B77EB-5A54-0C07-2406-B303EA637F14}"/>
+                <a16:creationId xmlns:a16="http://schemas.microsoft.com/office/drawing/2014/main" id="{E292A843-BE54-1647-FDC7-1D68FE675A4B}"/>
               </a:ext>
             </a:extLst>
           </p:cNvPr>
@@ -6960,7 +7015,7 @@
           <p:cNvPr id="3" name="Text Placeholder 2">
             <a:extLst>
               <a:ext uri="{FF2B5EF4-FFF2-40B4-BE49-F238E27FC236}">
-                <a16:creationId xmlns:a16="http://schemas.microsoft.com/office/drawing/2014/main" id="{FAEE4E71-5876-A2C4-FD26-CE548216836A}"/>
+                <a16:creationId xmlns:a16="http://schemas.microsoft.com/office/drawing/2014/main" id="{6BDFB0D9-8361-CCB3-4195-D528A68F2236}"/>
               </a:ext>
             </a:extLst>
           </p:cNvPr>
@@ -6978,17 +7033,17 @@
           <a:p>
             <a:r>
               <a:rPr lang="en-AU" dirty="0"/>
-              <a:t>Questionnaire</a:t>
-            </a:r>
-          </a:p>
-        </p:txBody>
-      </p:sp>
-      <p:sp>
-        <p:nvSpPr>
-          <p:cNvPr id="4" name="Text Placeholder 3">
+              <a:t>Building Blossom’s Base</a:t>
+            </a:r>
+          </a:p>
+        </p:txBody>
+      </p:sp>
+      <p:sp>
+        <p:nvSpPr>
+          <p:cNvPr id="6" name="Text Placeholder 5">
             <a:extLst>
               <a:ext uri="{FF2B5EF4-FFF2-40B4-BE49-F238E27FC236}">
-                <a16:creationId xmlns:a16="http://schemas.microsoft.com/office/drawing/2014/main" id="{E13AA2F1-3E8E-F220-694A-21D127C46EFF}"/>
+                <a16:creationId xmlns:a16="http://schemas.microsoft.com/office/drawing/2014/main" id="{61A9F0EB-F0D7-59BE-4967-A692BD83CCA5}"/>
               </a:ext>
             </a:extLst>
           </p:cNvPr>
@@ -7008,10 +7063,40 @@
           </a:p>
         </p:txBody>
       </p:sp>
+      <p:pic>
+        <p:nvPicPr>
+          <p:cNvPr id="10" name="Picture 9">
+            <a:extLst>
+              <a:ext uri="{FF2B5EF4-FFF2-40B4-BE49-F238E27FC236}">
+                <a16:creationId xmlns:a16="http://schemas.microsoft.com/office/drawing/2014/main" id="{41645670-171F-5E0C-C8B9-FE349EEC0AC5}"/>
+              </a:ext>
+            </a:extLst>
+          </p:cNvPr>
+          <p:cNvPicPr>
+            <a:picLocks noChangeAspect="1"/>
+          </p:cNvPicPr>
+          <p:nvPr/>
+        </p:nvPicPr>
+        <p:blipFill>
+          <a:blip r:embed="rId2"/>
+          <a:stretch>
+            <a:fillRect/>
+          </a:stretch>
+        </p:blipFill>
+        <p:spPr>
+          <a:xfrm>
+            <a:off x="2111174" y="1602491"/>
+            <a:ext cx="5683651" cy="4924425"/>
+          </a:xfrm>
+          <a:prstGeom prst="rect">
+            <a:avLst/>
+          </a:prstGeom>
+        </p:spPr>
+      </p:pic>
     </p:spTree>
     <p:extLst>
       <p:ext uri="{BB962C8B-B14F-4D97-AF65-F5344CB8AC3E}">
-        <p14:creationId xmlns:p14="http://schemas.microsoft.com/office/powerpoint/2010/main" val="923499938"/>
+        <p14:creationId xmlns:p14="http://schemas.microsoft.com/office/powerpoint/2010/main" val="2124365965"/>
       </p:ext>
     </p:extLst>
   </p:cSld>
@@ -7043,7 +7128,7 @@
           <p:cNvPr id="2" name="Slide Number Placeholder 1">
             <a:extLst>
               <a:ext uri="{FF2B5EF4-FFF2-40B4-BE49-F238E27FC236}">
-                <a16:creationId xmlns:a16="http://schemas.microsoft.com/office/drawing/2014/main" id="{159CE9FC-1BAC-3AC6-42B3-0FDE54699F51}"/>
+                <a16:creationId xmlns:a16="http://schemas.microsoft.com/office/drawing/2014/main" id="{FF3B77EB-5A54-0C07-2406-B303EA637F14}"/>
               </a:ext>
             </a:extLst>
           </p:cNvPr>
@@ -7073,7 +7158,7 @@
           <p:cNvPr id="3" name="Text Placeholder 2">
             <a:extLst>
               <a:ext uri="{FF2B5EF4-FFF2-40B4-BE49-F238E27FC236}">
-                <a16:creationId xmlns:a16="http://schemas.microsoft.com/office/drawing/2014/main" id="{B718FE30-23A8-AFDD-958C-2AFAA59B5734}"/>
+                <a16:creationId xmlns:a16="http://schemas.microsoft.com/office/drawing/2014/main" id="{FAEE4E71-5876-A2C4-FD26-CE548216836A}"/>
               </a:ext>
             </a:extLst>
           </p:cNvPr>
@@ -7091,7 +7176,7 @@
           <a:p>
             <a:r>
               <a:rPr lang="en-AU" dirty="0"/>
-              <a:t>Summary</a:t>
+              <a:t>Survey</a:t>
             </a:r>
           </a:p>
         </p:txBody>
@@ -7101,7 +7186,7 @@
           <p:cNvPr id="4" name="Text Placeholder 3">
             <a:extLst>
               <a:ext uri="{FF2B5EF4-FFF2-40B4-BE49-F238E27FC236}">
-                <a16:creationId xmlns:a16="http://schemas.microsoft.com/office/drawing/2014/main" id="{B463E487-B00A-BEE0-0687-C8749E4C9DEF}"/>
+                <a16:creationId xmlns:a16="http://schemas.microsoft.com/office/drawing/2014/main" id="{E13AA2F1-3E8E-F220-694A-21D127C46EFF}"/>
               </a:ext>
             </a:extLst>
           </p:cNvPr>
@@ -7117,35 +7202,157 @@
           <a:bodyPr/>
           <a:lstStyle/>
           <a:p>
-            <a:r>
-              <a:rPr lang="en-AU" dirty="0"/>
-              <a:t>AI – Artificial Intelligence</a:t>
-            </a:r>
-          </a:p>
-          <a:p>
-            <a:r>
-              <a:rPr lang="en-AU" dirty="0"/>
-              <a:t>Come up with 3 different examples of AI in our everyday life</a:t>
-            </a:r>
-          </a:p>
-          <a:p>
-            <a:r>
-              <a:rPr lang="en-AU" dirty="0"/>
-              <a:t>Explain the difference between predicting and understanding</a:t>
-            </a:r>
-          </a:p>
-          <a:p>
-            <a:r>
-              <a:rPr lang="en-AU" dirty="0"/>
-              <a:t>Why is it always important to check the answers AI gives us?</a:t>
-            </a:r>
-          </a:p>
-        </p:txBody>
-      </p:sp>
+            <a:endParaRPr lang="en-AU"/>
+          </a:p>
+        </p:txBody>
+      </p:sp>
+      <p:pic>
+        <p:nvPicPr>
+          <p:cNvPr id="6" name="Picture 5">
+            <a:extLst>
+              <a:ext uri="{FF2B5EF4-FFF2-40B4-BE49-F238E27FC236}">
+                <a16:creationId xmlns:a16="http://schemas.microsoft.com/office/drawing/2014/main" id="{7F24838B-E97C-997A-9E7A-D9D94BAE99B1}"/>
+              </a:ext>
+            </a:extLst>
+          </p:cNvPr>
+          <p:cNvPicPr>
+            <a:picLocks noChangeAspect="1"/>
+          </p:cNvPicPr>
+          <p:nvPr/>
+        </p:nvPicPr>
+        <p:blipFill>
+          <a:blip r:embed="rId2"/>
+          <a:stretch>
+            <a:fillRect/>
+          </a:stretch>
+        </p:blipFill>
+        <p:spPr>
+          <a:xfrm>
+            <a:off x="2290834" y="1659810"/>
+            <a:ext cx="5324331" cy="4648954"/>
+          </a:xfrm>
+          <a:prstGeom prst="rect">
+            <a:avLst/>
+          </a:prstGeom>
+        </p:spPr>
+      </p:pic>
     </p:spTree>
     <p:extLst>
       <p:ext uri="{BB962C8B-B14F-4D97-AF65-F5344CB8AC3E}">
-        <p14:creationId xmlns:p14="http://schemas.microsoft.com/office/powerpoint/2010/main" val="2852150750"/>
+        <p14:creationId xmlns:p14="http://schemas.microsoft.com/office/powerpoint/2010/main" val="494497314"/>
+      </p:ext>
+    </p:extLst>
+  </p:cSld>
+  <p:clrMapOvr>
+    <a:masterClrMapping/>
+  </p:clrMapOvr>
+</p:sld>
+</file>
+
+<file path=ppt/slides/slide19.xml><?xml version="1.0" encoding="utf-8"?>
+<p:sld xmlns:a="http://schemas.openxmlformats.org/drawingml/2006/main" xmlns:r="http://schemas.openxmlformats.org/officeDocument/2006/relationships" xmlns:p="http://schemas.openxmlformats.org/presentationml/2006/main">
+  <p:cSld>
+    <p:spTree>
+      <p:nvGrpSpPr>
+        <p:cNvPr id="1" name=""/>
+        <p:cNvGrpSpPr/>
+        <p:nvPr/>
+      </p:nvGrpSpPr>
+      <p:grpSpPr>
+        <a:xfrm>
+          <a:off x="0" y="0"/>
+          <a:ext cx="0" cy="0"/>
+          <a:chOff x="0" y="0"/>
+          <a:chExt cx="0" cy="0"/>
+        </a:xfrm>
+      </p:grpSpPr>
+      <p:sp>
+        <p:nvSpPr>
+          <p:cNvPr id="2" name="Slide Number Placeholder 1">
+            <a:extLst>
+              <a:ext uri="{FF2B5EF4-FFF2-40B4-BE49-F238E27FC236}">
+                <a16:creationId xmlns:a16="http://schemas.microsoft.com/office/drawing/2014/main" id="{FF3B77EB-5A54-0C07-2406-B303EA637F14}"/>
+              </a:ext>
+            </a:extLst>
+          </p:cNvPr>
+          <p:cNvSpPr>
+            <a:spLocks noGrp="1"/>
+          </p:cNvSpPr>
+          <p:nvPr>
+            <p:ph type="sldNum" sz="quarter" idx="12"/>
+          </p:nvPr>
+        </p:nvSpPr>
+        <p:spPr/>
+        <p:txBody>
+          <a:bodyPr/>
+          <a:lstStyle/>
+          <a:p>
+            <a:fld id="{B6F15528-21DE-4FAA-801E-634DDDAF4B2B}" type="slidenum">
+              <a:rPr lang="en-US" smtClean="0"/>
+              <a:pPr/>
+              <a:t>19</a:t>
+            </a:fld>
+            <a:endParaRPr lang="en-US"/>
+          </a:p>
+        </p:txBody>
+      </p:sp>
+      <p:sp>
+        <p:nvSpPr>
+          <p:cNvPr id="3" name="Text Placeholder 2">
+            <a:extLst>
+              <a:ext uri="{FF2B5EF4-FFF2-40B4-BE49-F238E27FC236}">
+                <a16:creationId xmlns:a16="http://schemas.microsoft.com/office/drawing/2014/main" id="{FAEE4E71-5876-A2C4-FD26-CE548216836A}"/>
+              </a:ext>
+            </a:extLst>
+          </p:cNvPr>
+          <p:cNvSpPr>
+            <a:spLocks noGrp="1"/>
+          </p:cNvSpPr>
+          <p:nvPr>
+            <p:ph type="body" sz="quarter" idx="13"/>
+          </p:nvPr>
+        </p:nvSpPr>
+        <p:spPr/>
+        <p:txBody>
+          <a:bodyPr/>
+          <a:lstStyle/>
+          <a:p>
+            <a:r>
+              <a:rPr lang="en-AU" dirty="0"/>
+              <a:t>Questionnaire</a:t>
+            </a:r>
+          </a:p>
+        </p:txBody>
+      </p:sp>
+      <p:sp>
+        <p:nvSpPr>
+          <p:cNvPr id="4" name="Text Placeholder 3">
+            <a:extLst>
+              <a:ext uri="{FF2B5EF4-FFF2-40B4-BE49-F238E27FC236}">
+                <a16:creationId xmlns:a16="http://schemas.microsoft.com/office/drawing/2014/main" id="{E13AA2F1-3E8E-F220-694A-21D127C46EFF}"/>
+              </a:ext>
+            </a:extLst>
+          </p:cNvPr>
+          <p:cNvSpPr>
+            <a:spLocks noGrp="1"/>
+          </p:cNvSpPr>
+          <p:nvPr>
+            <p:ph type="body" sz="quarter" idx="14"/>
+          </p:nvPr>
+        </p:nvSpPr>
+        <p:spPr/>
+        <p:txBody>
+          <a:bodyPr/>
+          <a:lstStyle/>
+          <a:p>
+            <a:endParaRPr lang="en-AU"/>
+          </a:p>
+        </p:txBody>
+      </p:sp>
+    </p:spTree>
+    <p:extLst>
+      <p:ext uri="{BB962C8B-B14F-4D97-AF65-F5344CB8AC3E}">
+        <p14:creationId xmlns:p14="http://schemas.microsoft.com/office/powerpoint/2010/main" val="923499938"/>
       </p:ext>
     </p:extLst>
   </p:cSld>
@@ -7389,6 +7596,140 @@
     <p:extLst>
       <p:ext uri="{BB962C8B-B14F-4D97-AF65-F5344CB8AC3E}">
         <p14:creationId xmlns:p14="http://schemas.microsoft.com/office/powerpoint/2010/main" val="2790588895"/>
+      </p:ext>
+    </p:extLst>
+  </p:cSld>
+  <p:clrMapOvr>
+    <a:masterClrMapping/>
+  </p:clrMapOvr>
+</p:sld>
+</file>
+
+<file path=ppt/slides/slide20.xml><?xml version="1.0" encoding="utf-8"?>
+<p:sld xmlns:a="http://schemas.openxmlformats.org/drawingml/2006/main" xmlns:r="http://schemas.openxmlformats.org/officeDocument/2006/relationships" xmlns:p="http://schemas.openxmlformats.org/presentationml/2006/main">
+  <p:cSld>
+    <p:spTree>
+      <p:nvGrpSpPr>
+        <p:cNvPr id="1" name=""/>
+        <p:cNvGrpSpPr/>
+        <p:nvPr/>
+      </p:nvGrpSpPr>
+      <p:grpSpPr>
+        <a:xfrm>
+          <a:off x="0" y="0"/>
+          <a:ext cx="0" cy="0"/>
+          <a:chOff x="0" y="0"/>
+          <a:chExt cx="0" cy="0"/>
+        </a:xfrm>
+      </p:grpSpPr>
+      <p:sp>
+        <p:nvSpPr>
+          <p:cNvPr id="2" name="Slide Number Placeholder 1">
+            <a:extLst>
+              <a:ext uri="{FF2B5EF4-FFF2-40B4-BE49-F238E27FC236}">
+                <a16:creationId xmlns:a16="http://schemas.microsoft.com/office/drawing/2014/main" id="{159CE9FC-1BAC-3AC6-42B3-0FDE54699F51}"/>
+              </a:ext>
+            </a:extLst>
+          </p:cNvPr>
+          <p:cNvSpPr>
+            <a:spLocks noGrp="1"/>
+          </p:cNvSpPr>
+          <p:nvPr>
+            <p:ph type="sldNum" sz="quarter" idx="12"/>
+          </p:nvPr>
+        </p:nvSpPr>
+        <p:spPr/>
+        <p:txBody>
+          <a:bodyPr/>
+          <a:lstStyle/>
+          <a:p>
+            <a:fld id="{B6F15528-21DE-4FAA-801E-634DDDAF4B2B}" type="slidenum">
+              <a:rPr lang="en-US" smtClean="0"/>
+              <a:pPr/>
+              <a:t>20</a:t>
+            </a:fld>
+            <a:endParaRPr lang="en-US"/>
+          </a:p>
+        </p:txBody>
+      </p:sp>
+      <p:sp>
+        <p:nvSpPr>
+          <p:cNvPr id="3" name="Text Placeholder 2">
+            <a:extLst>
+              <a:ext uri="{FF2B5EF4-FFF2-40B4-BE49-F238E27FC236}">
+                <a16:creationId xmlns:a16="http://schemas.microsoft.com/office/drawing/2014/main" id="{B718FE30-23A8-AFDD-958C-2AFAA59B5734}"/>
+              </a:ext>
+            </a:extLst>
+          </p:cNvPr>
+          <p:cNvSpPr>
+            <a:spLocks noGrp="1"/>
+          </p:cNvSpPr>
+          <p:nvPr>
+            <p:ph type="body" sz="quarter" idx="13"/>
+          </p:nvPr>
+        </p:nvSpPr>
+        <p:spPr/>
+        <p:txBody>
+          <a:bodyPr/>
+          <a:lstStyle/>
+          <a:p>
+            <a:r>
+              <a:rPr lang="en-AU" dirty="0"/>
+              <a:t>Summary</a:t>
+            </a:r>
+          </a:p>
+        </p:txBody>
+      </p:sp>
+      <p:sp>
+        <p:nvSpPr>
+          <p:cNvPr id="4" name="Text Placeholder 3">
+            <a:extLst>
+              <a:ext uri="{FF2B5EF4-FFF2-40B4-BE49-F238E27FC236}">
+                <a16:creationId xmlns:a16="http://schemas.microsoft.com/office/drawing/2014/main" id="{B463E487-B00A-BEE0-0687-C8749E4C9DEF}"/>
+              </a:ext>
+            </a:extLst>
+          </p:cNvPr>
+          <p:cNvSpPr>
+            <a:spLocks noGrp="1"/>
+          </p:cNvSpPr>
+          <p:nvPr>
+            <p:ph type="body" sz="quarter" idx="14"/>
+          </p:nvPr>
+        </p:nvSpPr>
+        <p:spPr/>
+        <p:txBody>
+          <a:bodyPr/>
+          <a:lstStyle/>
+          <a:p>
+            <a:r>
+              <a:rPr lang="en-AU" dirty="0"/>
+              <a:t>AI – Artificial Intelligence</a:t>
+            </a:r>
+          </a:p>
+          <a:p>
+            <a:r>
+              <a:rPr lang="en-AU" dirty="0"/>
+              <a:t>Come up with 3 different examples of AI in our everyday life</a:t>
+            </a:r>
+          </a:p>
+          <a:p>
+            <a:r>
+              <a:rPr lang="en-AU" dirty="0"/>
+              <a:t>Explain the difference between predicting and understanding</a:t>
+            </a:r>
+          </a:p>
+          <a:p>
+            <a:r>
+              <a:rPr lang="en-AU" dirty="0"/>
+              <a:t>Why is it always important to check the answers AI gives us?</a:t>
+            </a:r>
+          </a:p>
+        </p:txBody>
+      </p:sp>
+    </p:spTree>
+    <p:extLst>
+      <p:ext uri="{BB962C8B-B14F-4D97-AF65-F5344CB8AC3E}">
+        <p14:creationId xmlns:p14="http://schemas.microsoft.com/office/powerpoint/2010/main" val="2852150750"/>
       </p:ext>
     </p:extLst>
   </p:cSld>
@@ -9791,4 +10132,10 @@
     </a:ext>
   </a:extLst>
 </a:theme>
+</file>
+
+<file path=docMetadata/LabelInfo.xml><?xml version="1.0" encoding="utf-8"?>
+<clbl:labelList xmlns:clbl="http://schemas.microsoft.com/office/2020/mipLabelMetadata">
+  <clbl:label id="{72157dbb-e8bd-40dc-8d00-3f08c234ac47}" enabled="0" method="" siteId="{72157dbb-e8bd-40dc-8d00-3f08c234ac47}" removed="1"/>
+</clbl:labelList>
 </file>
</xml_diff>